<commit_message>
Measured latency copy, Render blueprint, real-runtime screenshots, deck + PDFs regenerated
Co-Authored-By: Claude Fable 5.1 <noreply@anthropic.com>
Claude-Session: https://claude.ai/code/session_018M7g59CPBebofDRQZHyA9Q
</commit_message>
<xml_diff>
--- a/docs/deck/Raksha-Pitch.pptx
+++ b/docs/deck/Raksha-Pitch.pptx
@@ -248,7 +248,7 @@
                 <c:formatCode>General</c:formatCode>
                 <c:ptCount val="4"/>
                 <c:pt idx="0">
-                  <c:v>4</c:v>
+                  <c:v>14</c:v>
                 </c:pt>
                 <c:pt idx="1">
                   <c:v>350</c:v>
@@ -2334,7 +2334,7 @@
                 <a:ea typeface="Calibri" pitchFamily="34" charset="-122"/>
                 <a:cs typeface="Calibri" pitchFamily="34" charset="-120"/>
               </a:rPr>
-              <a:t>The real-time scam-call shield. Sub-10 ms script recognition during a live call, powered by Moss. It interrupts before the OTP leaves your mouth, tells you what to say, and alerts someone you trust.</a:t>
+              <a:t>The real-time scam-call shield. Script recognition in about 10 ms during a live call, powered by Moss. It interrupts before the OTP leaves your mouth, tells you what to say, and alerts someone you trust.</a:t>
             </a:r>
             <a:endParaRPr lang="en-US" sz="1700" dirty="0"/>
           </a:p>
@@ -2915,7 +2915,7 @@
                 <a:ea typeface="Cambria" pitchFamily="34" charset="-122"/>
                 <a:cs typeface="Cambria" pitchFamily="34" charset="-120"/>
               </a:rPr>
-              <a:t>86%</a:t>
+              <a:t>100%</a:t>
             </a:r>
             <a:endParaRPr lang="en-US" sz="4000" dirty="0"/>
           </a:p>
@@ -3020,7 +3020,7 @@
                 <a:ea typeface="Cambria" pitchFamily="34" charset="-122"/>
                 <a:cs typeface="Cambria" pitchFamily="34" charset="-120"/>
               </a:rPr>
-              <a:t>4.1</a:t>
+              <a:t>4.3</a:t>
             </a:r>
             <a:endParaRPr lang="en-US" sz="4000" dirty="0"/>
           </a:p>
@@ -3125,7 +3125,7 @@
                 <a:ea typeface="Cambria" pitchFamily="34" charset="-122"/>
                 <a:cs typeface="Cambria" pitchFamily="34" charset="-120"/>
               </a:rPr>
-              <a:t>390 µs</a:t>
+              <a:t>13.8 ms</a:t>
             </a:r>
             <a:endParaRPr lang="en-US" sz="4000" dirty="0"/>
           </a:p>
@@ -3230,7 +3230,7 @@
                 <a:ea typeface="Cambria" pitchFamily="34" charset="-122"/>
                 <a:cs typeface="Cambria" pitchFamily="34" charset="-120"/>
               </a:rPr>
-              <a:t>1.5 ms</a:t>
+              <a:t>26.7 ms</a:t>
             </a:r>
             <a:endParaRPr lang="en-US" sz="4000" dirty="0"/>
           </a:p>
@@ -3308,7 +3308,7 @@
                 <a:ea typeface="Calibri" pitchFamily="34" charset="-122"/>
                 <a:cs typeface="Calibri" pitchFamily="34" charset="-120"/>
               </a:rPr>
-              <a:t>Full turn-by-turn report: docs/eval/REPORT.md  ·  runtime: offline fallback (rerun with Moss credentials)</a:t>
+              <a:t>Full turn-by-turn report: docs/eval/REPORT.md  ·  runtime: Moss, in-process</a:t>
             </a:r>
             <a:endParaRPr lang="en-US" sz="1100" dirty="0"/>
           </a:p>
@@ -4148,7 +4148,7 @@
                 <a:ea typeface="Calibri" pitchFamily="34" charset="-122"/>
                 <a:cs typeface="Calibri" pitchFamily="34" charset="-120"/>
               </a:rPr>
-              <a:t>LLM coach, ≤ 6 calls on an 8B model: ≈ ₹0.02</a:t>
+              <a:t>LLM coach, ≤ 6 calls on a 20B model: ≈ ₹0.02</a:t>
             </a:r>
             <a:endParaRPr lang="en-US" sz="1200" dirty="0"/>
           </a:p>
@@ -7242,7 +7242,7 @@
                 <a:ea typeface="Calibri" pitchFamily="34" charset="-122"/>
                 <a:cs typeface="Calibri" pitchFamily="34" charset="-120"/>
               </a:rPr>
-              <a:t>Recognised in ≈ 3 ms</a:t>
+              <a:t>Recognised in ≈ 10 ms</a:t>
             </a:r>
             <a:endParaRPr lang="en-US" sz="1500" dirty="0"/>
           </a:p>
@@ -7281,7 +7281,7 @@
                 <a:ea typeface="Calibri" pitchFamily="34" charset="-122"/>
                 <a:cs typeface="Calibri" pitchFamily="34" charset="-120"/>
               </a:rPr>
-              <a:t>Matched against 409 real scam lines in-process with Moss. No vector DB, no round-trip.</a:t>
+              <a:t>Matched against 409 real scam lines in-process with Moss, including on-device embedding. No vector DB, no round-trip.</a:t>
             </a:r>
             <a:endParaRPr lang="en-US" sz="1250" dirty="0"/>
           </a:p>
@@ -7662,7 +7662,7 @@
                 <a:ea typeface="Calibri" pitchFamily="34" charset="-122"/>
                 <a:cs typeface="Calibri" pitchFamily="34" charset="-120"/>
               </a:rPr>
-              <a:t>FAST PATH · EVERY FRAGMENT · ≈ 3 MS</a:t>
+              <a:t>FAST PATH · EVERY FRAGMENT · ≈ 10 MS</a:t>
             </a:r>
             <a:endParaRPr lang="en-US" sz="1000" dirty="0"/>
           </a:p>
@@ -7898,7 +7898,7 @@
                 <a:ea typeface="Calibri" pitchFamily="34" charset="-122"/>
                 <a:cs typeface="Calibri" pitchFamily="34" charset="-120"/>
               </a:rPr>
-              <a:t>An 8B model (Groq) returns a JSON contract: verdict · explanation · say this · action.</a:t>
+              <a:t>A 20B model (Groq) returns a JSON contract: verdict · explanation · say this · action.</a:t>
             </a:r>
             <a:endParaRPr lang="en-US" sz="1350" dirty="0"/>
           </a:p>
@@ -8515,7 +8515,7 @@
                 <a:ea typeface="Calibri" pitchFamily="34" charset="-122"/>
                 <a:cs typeface="Calibri" pitchFamily="34" charset="-120"/>
               </a:rPr>
-              <a:t>raksha-playbook (409 lines) loaded at boot. Every fragment embedded and searched locally. Raw cosine, calibrated. The entire hot path, ≈ 3 ms, unmetered.</a:t>
+              <a:t>raksha-playbook (409 lines) loaded at boot. Every fragment embedded and searched locally via queryMultiIndex (raw cosine, calibrated). The entire hot path ≈ 10 ms, unmetered.</a:t>
             </a:r>
             <a:endParaRPr lang="en-US" sz="1250" dirty="0"/>
           </a:p>
@@ -9286,7 +9286,7 @@
                 <a:ea typeface="Cambria" pitchFamily="34" charset="-122"/>
                 <a:cs typeface="Cambria" pitchFamily="34" charset="-120"/>
               </a:rPr>
-              <a:t>≈ 0.2%</a:t>
+              <a:t>≈ 1%</a:t>
             </a:r>
             <a:endParaRPr lang="en-US" sz="2400" dirty="0"/>
           </a:p>
@@ -9325,7 +9325,7 @@
                 <a:ea typeface="Calibri" pitchFamily="34" charset="-122"/>
                 <a:cs typeface="Calibri" pitchFamily="34" charset="-120"/>
               </a:rPr>
-              <a:t>of the sentence consumed by Moss retrieval (p95 ≈ 5 ms)</a:t>
+              <a:t>of the sentence consumed by Moss retrieval (p95 ≈ 27 ms measured)</a:t>
             </a:r>
             <a:endParaRPr lang="en-US" sz="1150" dirty="0"/>
           </a:p>

</xml_diff>

<commit_message>
Judge-driven iteration: 18-scenario eval + benign-fragment test, latency benchmark, intel abuse controls, data-handling/scaling/onboarding/pricing docs
Co-Authored-By: Claude Fable 5.1 <noreply@anthropic.com>
Claude-Session: https://claude.ai/code/session_018M7g59CPBebofDRQZHyA9Q
</commit_message>
<xml_diff>
--- a/docs/deck/Raksha-Pitch.pptx
+++ b/docs/deck/Raksha-Pitch.pptx
@@ -2639,7 +2639,7 @@
                 <a:ea typeface="Calibri" pitchFamily="34" charset="-122"/>
                 <a:cs typeface="Calibri" pitchFamily="34" charset="-120"/>
               </a:rPr>
-              <a:t>Nine full call transcripts replayed through the real engine — seven scams, two genuine calls — plus a live benchmark page anyone can run against the deployed instance.</a:t>
+              <a:t>Eighteen full call transcripts replayed through the real Moss runtime — ten scams, eight genuine calls — plus a live benchmark page anyone can run against the deployed instance.</a:t>
             </a:r>
             <a:endParaRPr lang="en-US" sz="1500" dirty="0"/>
           </a:p>
@@ -2915,7 +2915,7 @@
                 <a:ea typeface="Cambria" pitchFamily="34" charset="-122"/>
                 <a:cs typeface="Cambria" pitchFamily="34" charset="-120"/>
               </a:rPr>
-              <a:t>100%</a:t>
+              <a:t>90%</a:t>
             </a:r>
             <a:endParaRPr lang="en-US" sz="4000" dirty="0"/>
           </a:p>
@@ -3020,7 +3020,7 @@
                 <a:ea typeface="Cambria" pitchFamily="34" charset="-122"/>
                 <a:cs typeface="Cambria" pitchFamily="34" charset="-120"/>
               </a:rPr>
-              <a:t>4.3</a:t>
+              <a:t>3.9</a:t>
             </a:r>
             <a:endParaRPr lang="en-US" sz="4000" dirty="0"/>
           </a:p>
@@ -3125,7 +3125,7 @@
                 <a:ea typeface="Cambria" pitchFamily="34" charset="-122"/>
                 <a:cs typeface="Cambria" pitchFamily="34" charset="-120"/>
               </a:rPr>
-              <a:t>13.8 ms</a:t>
+              <a:t>9.3 ms</a:t>
             </a:r>
             <a:endParaRPr lang="en-US" sz="4000" dirty="0"/>
           </a:p>
@@ -3230,7 +3230,7 @@
                 <a:ea typeface="Cambria" pitchFamily="34" charset="-122"/>
                 <a:cs typeface="Cambria" pitchFamily="34" charset="-120"/>
               </a:rPr>
-              <a:t>26.7 ms</a:t>
+              <a:t>18.4 ms</a:t>
             </a:r>
             <a:endParaRPr lang="en-US" sz="4000" dirty="0"/>
           </a:p>
@@ -4540,7 +4540,7 @@
                 <a:ea typeface="Calibri" pitchFamily="34" charset="-122"/>
                 <a:cs typeface="Calibri" pitchFamily="34" charset="-120"/>
               </a:rPr>
-              <a:t>Web reference implementation, deployed. 9 scenarios, live mic, recordings, guardian, community intel, eval.</a:t>
+              <a:t>Web reference implementation, deployed. 18 scenarios, live mic, recordings, guardian, community intel, eval.</a:t>
             </a:r>
             <a:endParaRPr lang="en-US" sz="1250" dirty="0"/>
           </a:p>

</xml_diff>

<commit_message>
Cloud Run one-command deploy script; load-test capacity numbers; eval on the new Moss project; deck + PDFs regenerated
Co-Authored-By: Claude Fable 5.1 <noreply@anthropic.com>
Claude-Session: https://claude.ai/code/session_018M7g59CPBebofDRQZHyA9Q
</commit_message>
<xml_diff>
--- a/docs/deck/Raksha-Pitch.pptx
+++ b/docs/deck/Raksha-Pitch.pptx
@@ -3125,7 +3125,7 @@
                 <a:ea typeface="Cambria" pitchFamily="34" charset="-122"/>
                 <a:cs typeface="Cambria" pitchFamily="34" charset="-120"/>
               </a:rPr>
-              <a:t>9.3 ms</a:t>
+              <a:t>8.0 ms</a:t>
             </a:r>
             <a:endParaRPr lang="en-US" sz="4000" dirty="0"/>
           </a:p>
@@ -3230,7 +3230,7 @@
                 <a:ea typeface="Cambria" pitchFamily="34" charset="-122"/>
                 <a:cs typeface="Cambria" pitchFamily="34" charset="-120"/>
               </a:rPr>
-              <a:t>18.4 ms</a:t>
+              <a:t>14.9 ms</a:t>
             </a:r>
             <a:endParaRPr lang="en-US" sz="4000" dirty="0"/>
           </a:p>
@@ -8630,7 +8630,7 @@
                 <a:ea typeface="Calibri" pitchFamily="34" charset="-122"/>
                 <a:cs typeface="Calibri" pitchFamily="34" charset="-120"/>
               </a:rPr>
-              <a:t>A session per call</a:t>
+              <a:t>Call memory in a session</a:t>
             </a:r>
             <a:endParaRPr lang="en-US" sz="1600" dirty="0"/>
           </a:p>
@@ -8669,7 +8669,7 @@
                 <a:ea typeface="Calibri" pitchFamily="34" charset="-122"/>
                 <a:cs typeface="Calibri" pitchFamily="34" charset="-120"/>
               </a:rPr>
-              <a:t>client.session() opens a local index of the call's own turns. The guardian's “what did they ask for?” is a semantic query over it. Never pushed — memory dies with the call.</a:t>
+              <a:t>Every live turn goes into one in-process Moss session tagged by call id; the guardian's “what did they ask for?” is a filtered semantic query over it. Never pushed — a call's turns are deleted when it ends.</a:t>
             </a:r>
             <a:endParaRPr lang="en-US" sz="1250" dirty="0"/>
           </a:p>

</xml_diff>